<commit_message>
Fix presentation image aspect ratios
</commit_message>
<xml_diff>
--- a/slides/output/openfugu_principles_training_cost.pptx
+++ b/slides/output/openfugu_principles_training_cost.pptx
@@ -2059,65 +2059,7 @@
       </p:sp>
       <p:sp>
         <p:nvSpPr>
-          <p:cNvPr id="3" name="Shape 1"/>
-          <p:cNvSpPr/>
-          <p:nvPr/>
-        </p:nvSpPr>
-        <p:spPr>
-          <a:xfrm>
-            <a:off x="5989320" y="0"/>
-            <a:ext cx="3154680" cy="5143500"/>
-          </a:xfrm>
-          <a:prstGeom prst="rect">
-            <a:avLst/>
-          </a:prstGeom>
-          <a:solidFill>
-            <a:srgbClr val="2A9D8F">
-              <a:alpha val="92000"/>
-            </a:srgbClr>
-          </a:solidFill>
-          <a:ln w="12700">
-            <a:solidFill>
-              <a:srgbClr val="2A9D8F">
-                <a:alpha val="0"/>
-              </a:srgbClr>
-            </a:solidFill>
-            <a:prstDash val="solid"/>
-          </a:ln>
-        </p:spPr>
-      </p:sp>
-      <p:sp>
-        <p:nvSpPr>
-          <p:cNvPr id="4" name="Shape 2"/>
-          <p:cNvSpPr/>
-          <p:nvPr/>
-        </p:nvSpPr>
-        <p:spPr>
-          <a:xfrm>
-            <a:off x="6263640" y="502920"/>
-            <a:ext cx="2148840" cy="4160520"/>
-          </a:xfrm>
-          <a:prstGeom prst="rect">
-            <a:avLst/>
-          </a:prstGeom>
-          <a:solidFill>
-            <a:srgbClr val="FFFFFF">
-              <a:alpha val="96000"/>
-            </a:srgbClr>
-          </a:solidFill>
-          <a:ln w="12700">
-            <a:solidFill>
-              <a:srgbClr val="FFFFFF">
-                <a:alpha val="20000"/>
-              </a:srgbClr>
-            </a:solidFill>
-            <a:prstDash val="solid"/>
-          </a:ln>
-        </p:spPr>
-      </p:sp>
-      <p:sp>
-        <p:nvSpPr>
-          <p:cNvPr id="5" name="Text 3"/>
+          <p:cNvPr id="3" name="Text 1"/>
           <p:cNvSpPr/>
           <p:nvPr/>
         </p:nvSpPr>
@@ -2156,7 +2098,7 @@
       </p:sp>
       <p:sp>
         <p:nvSpPr>
-          <p:cNvPr id="6" name="Text 4"/>
+          <p:cNvPr id="4" name="Text 2"/>
           <p:cNvSpPr/>
           <p:nvPr/>
         </p:nvSpPr>
@@ -2195,14 +2137,14 @@
       </p:sp>
       <p:sp>
         <p:nvSpPr>
-          <p:cNvPr id="7" name="Text 5"/>
-          <p:cNvSpPr/>
-          <p:nvPr/>
-        </p:nvSpPr>
-        <p:spPr>
-          <a:xfrm>
-            <a:off x="603504" y="2395728"/>
-            <a:ext cx="4846320" cy="530352"/>
+          <p:cNvPr id="5" name="Text 3"/>
+          <p:cNvSpPr/>
+          <p:nvPr/>
+        </p:nvSpPr>
+        <p:spPr>
+          <a:xfrm>
+            <a:off x="603504" y="2359152"/>
+            <a:ext cx="6858000" cy="384048"/>
           </a:xfrm>
           <a:prstGeom prst="rect">
             <a:avLst/>
@@ -2236,13 +2178,13 @@
       </p:sp>
       <p:sp>
         <p:nvSpPr>
-          <p:cNvPr id="8" name="Shape 6"/>
-          <p:cNvSpPr/>
-          <p:nvPr/>
-        </p:nvSpPr>
-        <p:spPr>
-          <a:xfrm>
-            <a:off x="603504" y="3246120"/>
+          <p:cNvPr id="6" name="Shape 4"/>
+          <p:cNvSpPr/>
+          <p:nvPr/>
+        </p:nvSpPr>
+        <p:spPr>
+          <a:xfrm>
+            <a:off x="603504" y="2971800"/>
             <a:ext cx="1325880" cy="256032"/>
           </a:xfrm>
           <a:prstGeom prst="roundRect">
@@ -2263,13 +2205,13 @@
       </p:sp>
       <p:sp>
         <p:nvSpPr>
-          <p:cNvPr id="9" name="Text 7"/>
-          <p:cNvSpPr/>
-          <p:nvPr/>
-        </p:nvSpPr>
-        <p:spPr>
-          <a:xfrm>
-            <a:off x="676656" y="3300984"/>
+          <p:cNvPr id="7" name="Text 5"/>
+          <p:cNvSpPr/>
+          <p:nvPr/>
+        </p:nvSpPr>
+        <p:spPr>
+          <a:xfrm>
+            <a:off x="676656" y="3026664"/>
             <a:ext cx="1179576" cy="128016"/>
           </a:xfrm>
           <a:prstGeom prst="rect">
@@ -2304,13 +2246,13 @@
       </p:sp>
       <p:sp>
         <p:nvSpPr>
-          <p:cNvPr id="10" name="Shape 8"/>
-          <p:cNvSpPr/>
-          <p:nvPr/>
-        </p:nvSpPr>
-        <p:spPr>
-          <a:xfrm>
-            <a:off x="2057400" y="3246120"/>
+          <p:cNvPr id="8" name="Shape 6"/>
+          <p:cNvSpPr/>
+          <p:nvPr/>
+        </p:nvSpPr>
+        <p:spPr>
+          <a:xfrm>
+            <a:off x="2057400" y="2971800"/>
             <a:ext cx="1417320" cy="256032"/>
           </a:xfrm>
           <a:prstGeom prst="roundRect">
@@ -2331,13 +2273,13 @@
       </p:sp>
       <p:sp>
         <p:nvSpPr>
-          <p:cNvPr id="11" name="Text 9"/>
-          <p:cNvSpPr/>
-          <p:nvPr/>
-        </p:nvSpPr>
-        <p:spPr>
-          <a:xfrm>
-            <a:off x="2130552" y="3300984"/>
+          <p:cNvPr id="9" name="Text 7"/>
+          <p:cNvSpPr/>
+          <p:nvPr/>
+        </p:nvSpPr>
+        <p:spPr>
+          <a:xfrm>
+            <a:off x="2130552" y="3026664"/>
             <a:ext cx="1271016" cy="128016"/>
           </a:xfrm>
           <a:prstGeom prst="rect">
@@ -2372,13 +2314,13 @@
       </p:sp>
       <p:sp>
         <p:nvSpPr>
-          <p:cNvPr id="12" name="Shape 10"/>
-          <p:cNvSpPr/>
-          <p:nvPr/>
-        </p:nvSpPr>
-        <p:spPr>
-          <a:xfrm>
-            <a:off x="3611880" y="3246120"/>
+          <p:cNvPr id="10" name="Shape 8"/>
+          <p:cNvSpPr/>
+          <p:nvPr/>
+        </p:nvSpPr>
+        <p:spPr>
+          <a:xfrm>
+            <a:off x="3611880" y="2971800"/>
             <a:ext cx="1143000" cy="256032"/>
           </a:xfrm>
           <a:prstGeom prst="roundRect">
@@ -2399,13 +2341,13 @@
       </p:sp>
       <p:sp>
         <p:nvSpPr>
-          <p:cNvPr id="13" name="Text 11"/>
-          <p:cNvSpPr/>
-          <p:nvPr/>
-        </p:nvSpPr>
-        <p:spPr>
-          <a:xfrm>
-            <a:off x="3685032" y="3300984"/>
+          <p:cNvPr id="11" name="Text 9"/>
+          <p:cNvSpPr/>
+          <p:nvPr/>
+        </p:nvSpPr>
+        <p:spPr>
+          <a:xfrm>
+            <a:off x="3685032" y="3026664"/>
             <a:ext cx="996696" cy="128016"/>
           </a:xfrm>
           <a:prstGeom prst="rect">
@@ -2438,9 +2380,38 @@
           </a:p>
         </p:txBody>
       </p:sp>
+      <p:sp>
+        <p:nvSpPr>
+          <p:cNvPr id="12" name="Shape 10"/>
+          <p:cNvSpPr/>
+          <p:nvPr/>
+        </p:nvSpPr>
+        <p:spPr>
+          <a:xfrm>
+            <a:off x="621792" y="3520440"/>
+            <a:ext cx="7909560" cy="987552"/>
+          </a:xfrm>
+          <a:prstGeom prst="roundRect">
+            <a:avLst>
+              <a:gd name="adj" fmla="val 5556"/>
+            </a:avLst>
+          </a:prstGeom>
+          <a:solidFill>
+            <a:srgbClr val="FFFFFF"/>
+          </a:solidFill>
+          <a:ln w="12700">
+            <a:solidFill>
+              <a:srgbClr val="D4D4D4">
+                <a:alpha val="90000"/>
+              </a:srgbClr>
+            </a:solidFill>
+            <a:prstDash val="solid"/>
+          </a:ln>
+        </p:spPr>
+      </p:sp>
       <p:pic>
         <p:nvPicPr>
-          <p:cNvPr id="14" name="Image 0" descr="/Users/fupengcheng/Documents/OpenFugu/assets/01_routing.png">    </p:cNvPr>
+          <p:cNvPr id="13" name="Image 0" descr="/Users/fupengcheng/Documents/OpenFugu/assets/01_routing.png">    </p:cNvPr>
           <p:cNvPicPr>
             <a:picLocks noChangeAspect="1"/>
           </p:cNvPicPr>
@@ -2454,8 +2425,8 @@
         </p:blipFill>
         <p:spPr>
           <a:xfrm>
-            <a:off x="6144768" y="713232"/>
-            <a:ext cx="2395728" cy="3337560"/>
+            <a:off x="621792" y="3531695"/>
+            <a:ext cx="7909560" cy="965042"/>
           </a:xfrm>
           <a:prstGeom prst="rect">
             <a:avLst/>
@@ -2464,7 +2435,7 @@
       </p:pic>
       <p:sp>
         <p:nvSpPr>
-          <p:cNvPr id="15" name="Text 12"/>
+          <p:cNvPr id="14" name="Text 11"/>
           <p:cNvSpPr/>
           <p:nvPr/>
         </p:nvSpPr>
@@ -9350,9 +9321,38 @@
           </a:p>
         </p:txBody>
       </p:sp>
+      <p:sp>
+        <p:nvSpPr>
+          <p:cNvPr id="32" name="Shape 30"/>
+          <p:cNvSpPr/>
+          <p:nvPr/>
+        </p:nvSpPr>
+        <p:spPr>
+          <a:xfrm>
+            <a:off x="685800" y="3273552"/>
+            <a:ext cx="7818120" cy="987552"/>
+          </a:xfrm>
+          <a:prstGeom prst="roundRect">
+            <a:avLst>
+              <a:gd name="adj" fmla="val 5556"/>
+            </a:avLst>
+          </a:prstGeom>
+          <a:solidFill>
+            <a:srgbClr val="FFFFFF"/>
+          </a:solidFill>
+          <a:ln w="12700">
+            <a:solidFill>
+              <a:srgbClr val="D4D4D4">
+                <a:alpha val="90000"/>
+              </a:srgbClr>
+            </a:solidFill>
+            <a:prstDash val="solid"/>
+          </a:ln>
+        </p:spPr>
+      </p:sp>
       <p:pic>
         <p:nvPicPr>
-          <p:cNvPr id="32" name="Image 0" descr="/Users/fupengcheng/Documents/OpenFugu/assets/01_routing.png">    </p:cNvPr>
+          <p:cNvPr id="33" name="Image 0" descr="/Users/fupengcheng/Documents/OpenFugu/assets/01_routing.png">    </p:cNvPr>
           <p:cNvPicPr>
             <a:picLocks noChangeAspect="1"/>
           </p:cNvPicPr>
@@ -9366,8 +9366,8 @@
         </p:blipFill>
         <p:spPr>
           <a:xfrm>
-            <a:off x="685800" y="3246120"/>
-            <a:ext cx="7818120" cy="1170432"/>
+            <a:off x="685800" y="3290385"/>
+            <a:ext cx="7818120" cy="953885"/>
           </a:xfrm>
           <a:prstGeom prst="rect">
             <a:avLst/>
@@ -9376,7 +9376,7 @@
       </p:pic>
       <p:sp>
         <p:nvSpPr>
-          <p:cNvPr id="33" name="Text 30"/>
+          <p:cNvPr id="34" name="Text 31"/>
           <p:cNvSpPr/>
           <p:nvPr/>
         </p:nvSpPr>
@@ -10301,9 +10301,38 @@
           </a:p>
         </p:txBody>
       </p:sp>
+      <p:sp>
+        <p:nvSpPr>
+          <p:cNvPr id="7" name="Shape 5"/>
+          <p:cNvSpPr/>
+          <p:nvPr/>
+        </p:nvSpPr>
+        <p:spPr>
+          <a:xfrm>
+            <a:off x="621792" y="1024128"/>
+            <a:ext cx="7909560" cy="1078992"/>
+          </a:xfrm>
+          <a:prstGeom prst="roundRect">
+            <a:avLst>
+              <a:gd name="adj" fmla="val 5085"/>
+            </a:avLst>
+          </a:prstGeom>
+          <a:solidFill>
+            <a:srgbClr val="FFFFFF"/>
+          </a:solidFill>
+          <a:ln w="12700">
+            <a:solidFill>
+              <a:srgbClr val="D4D4D4">
+                <a:alpha val="90000"/>
+              </a:srgbClr>
+            </a:solidFill>
+            <a:prstDash val="solid"/>
+          </a:ln>
+        </p:spPr>
+      </p:sp>
       <p:pic>
         <p:nvPicPr>
-          <p:cNvPr id="7" name="Image 0" descr="/Users/fupengcheng/Documents/OpenFugu/assets/03_paramvec.png">    </p:cNvPr>
+          <p:cNvPr id="8" name="Image 0" descr="/Users/fupengcheng/Documents/OpenFugu/assets/03_paramvec.png">    </p:cNvPr>
           <p:cNvPicPr>
             <a:picLocks noChangeAspect="1"/>
           </p:cNvPicPr>
@@ -10317,8 +10346,8 @@
         </p:blipFill>
         <p:spPr>
           <a:xfrm>
-            <a:off x="502920" y="1051560"/>
-            <a:ext cx="3794760" cy="3154680"/>
+            <a:off x="630371" y="1024128"/>
+            <a:ext cx="7892402" cy="1078992"/>
           </a:xfrm>
           <a:prstGeom prst="rect">
             <a:avLst/>
@@ -10327,18 +10356,18 @@
       </p:pic>
       <p:sp>
         <p:nvSpPr>
-          <p:cNvPr id="8" name="Shape 5"/>
-          <p:cNvSpPr/>
-          <p:nvPr/>
-        </p:nvSpPr>
-        <p:spPr>
-          <a:xfrm>
-            <a:off x="4617720" y="1024128"/>
-            <a:ext cx="3977640" cy="841248"/>
+          <p:cNvPr id="9" name="Shape 6"/>
+          <p:cNvSpPr/>
+          <p:nvPr/>
+        </p:nvSpPr>
+        <p:spPr>
+          <a:xfrm>
+            <a:off x="658368" y="2514600"/>
+            <a:ext cx="2514600" cy="1298448"/>
           </a:xfrm>
           <a:prstGeom prst="roundRect">
             <a:avLst>
-              <a:gd name="adj" fmla="val 6522"/>
+              <a:gd name="adj" fmla="val 4225"/>
             </a:avLst>
           </a:prstGeom>
           <a:solidFill>
@@ -10356,14 +10385,14 @@
       </p:sp>
       <p:sp>
         <p:nvSpPr>
-          <p:cNvPr id="9" name="Shape 6"/>
-          <p:cNvSpPr/>
-          <p:nvPr/>
-        </p:nvSpPr>
-        <p:spPr>
-          <a:xfrm>
-            <a:off x="4617720" y="1024128"/>
-            <a:ext cx="73152" cy="841248"/>
+          <p:cNvPr id="10" name="Shape 7"/>
+          <p:cNvSpPr/>
+          <p:nvPr/>
+        </p:nvSpPr>
+        <p:spPr>
+          <a:xfrm>
+            <a:off x="658368" y="2514600"/>
+            <a:ext cx="73152" cy="1298448"/>
           </a:xfrm>
           <a:prstGeom prst="rect">
             <a:avLst/>
@@ -10381,14 +10410,14 @@
       </p:sp>
       <p:sp>
         <p:nvSpPr>
-          <p:cNvPr id="10" name="Text 7"/>
-          <p:cNvSpPr/>
-          <p:nvPr/>
-        </p:nvSpPr>
-        <p:spPr>
-          <a:xfrm>
-            <a:off x="4818888" y="1188720"/>
-            <a:ext cx="3666744" cy="201168"/>
+          <p:cNvPr id="11" name="Text 8"/>
+          <p:cNvSpPr/>
+          <p:nvPr/>
+        </p:nvSpPr>
+        <p:spPr>
+          <a:xfrm>
+            <a:off x="859536" y="2679192"/>
+            <a:ext cx="2203704" cy="201168"/>
           </a:xfrm>
           <a:prstGeom prst="rect">
             <a:avLst/>
@@ -10422,14 +10451,14 @@
       </p:sp>
       <p:sp>
         <p:nvSpPr>
-          <p:cNvPr id="11" name="Text 8"/>
-          <p:cNvSpPr/>
-          <p:nvPr/>
-        </p:nvSpPr>
-        <p:spPr>
-          <a:xfrm>
-            <a:off x="4818888" y="1527048"/>
-            <a:ext cx="3666744" cy="219456"/>
+          <p:cNvPr id="12" name="Text 9"/>
+          <p:cNvSpPr/>
+          <p:nvPr/>
+        </p:nvSpPr>
+        <p:spPr>
+          <a:xfrm>
+            <a:off x="859536" y="3017520"/>
+            <a:ext cx="2203704" cy="676656"/>
           </a:xfrm>
           <a:prstGeom prst="rect">
             <a:avLst/>
@@ -10463,18 +10492,18 @@
       </p:sp>
       <p:sp>
         <p:nvSpPr>
-          <p:cNvPr id="12" name="Shape 9"/>
-          <p:cNvSpPr/>
-          <p:nvPr/>
-        </p:nvSpPr>
-        <p:spPr>
-          <a:xfrm>
-            <a:off x="4617720" y="2057400"/>
-            <a:ext cx="3977640" cy="841248"/>
+          <p:cNvPr id="13" name="Shape 10"/>
+          <p:cNvSpPr/>
+          <p:nvPr/>
+        </p:nvSpPr>
+        <p:spPr>
+          <a:xfrm>
+            <a:off x="3364992" y="2514600"/>
+            <a:ext cx="2514600" cy="1298448"/>
           </a:xfrm>
           <a:prstGeom prst="roundRect">
             <a:avLst>
-              <a:gd name="adj" fmla="val 6522"/>
+              <a:gd name="adj" fmla="val 4225"/>
             </a:avLst>
           </a:prstGeom>
           <a:solidFill>
@@ -10492,14 +10521,14 @@
       </p:sp>
       <p:sp>
         <p:nvSpPr>
-          <p:cNvPr id="13" name="Shape 10"/>
-          <p:cNvSpPr/>
-          <p:nvPr/>
-        </p:nvSpPr>
-        <p:spPr>
-          <a:xfrm>
-            <a:off x="4617720" y="2057400"/>
-            <a:ext cx="73152" cy="841248"/>
+          <p:cNvPr id="14" name="Shape 11"/>
+          <p:cNvSpPr/>
+          <p:nvPr/>
+        </p:nvSpPr>
+        <p:spPr>
+          <a:xfrm>
+            <a:off x="3364992" y="2514600"/>
+            <a:ext cx="73152" cy="1298448"/>
           </a:xfrm>
           <a:prstGeom prst="rect">
             <a:avLst/>
@@ -10517,14 +10546,14 @@
       </p:sp>
       <p:sp>
         <p:nvSpPr>
-          <p:cNvPr id="14" name="Text 11"/>
-          <p:cNvSpPr/>
-          <p:nvPr/>
-        </p:nvSpPr>
-        <p:spPr>
-          <a:xfrm>
-            <a:off x="4818888" y="2221992"/>
-            <a:ext cx="3666744" cy="201168"/>
+          <p:cNvPr id="15" name="Text 12"/>
+          <p:cNvSpPr/>
+          <p:nvPr/>
+        </p:nvSpPr>
+        <p:spPr>
+          <a:xfrm>
+            <a:off x="3566160" y="2679192"/>
+            <a:ext cx="2203704" cy="201168"/>
           </a:xfrm>
           <a:prstGeom prst="rect">
             <a:avLst/>
@@ -10558,14 +10587,14 @@
       </p:sp>
       <p:sp>
         <p:nvSpPr>
-          <p:cNvPr id="15" name="Text 12"/>
-          <p:cNvSpPr/>
-          <p:nvPr/>
-        </p:nvSpPr>
-        <p:spPr>
-          <a:xfrm>
-            <a:off x="4818888" y="2560320"/>
-            <a:ext cx="3666744" cy="219456"/>
+          <p:cNvPr id="16" name="Text 13"/>
+          <p:cNvSpPr/>
+          <p:nvPr/>
+        </p:nvSpPr>
+        <p:spPr>
+          <a:xfrm>
+            <a:off x="3566160" y="3017520"/>
+            <a:ext cx="2203704" cy="676656"/>
           </a:xfrm>
           <a:prstGeom prst="rect">
             <a:avLst/>
@@ -10599,18 +10628,18 @@
       </p:sp>
       <p:sp>
         <p:nvSpPr>
-          <p:cNvPr id="16" name="Shape 13"/>
-          <p:cNvSpPr/>
-          <p:nvPr/>
-        </p:nvSpPr>
-        <p:spPr>
-          <a:xfrm>
-            <a:off x="4617720" y="3090672"/>
-            <a:ext cx="3977640" cy="841248"/>
+          <p:cNvPr id="17" name="Shape 14"/>
+          <p:cNvSpPr/>
+          <p:nvPr/>
+        </p:nvSpPr>
+        <p:spPr>
+          <a:xfrm>
+            <a:off x="6080760" y="2514600"/>
+            <a:ext cx="2514600" cy="1298448"/>
           </a:xfrm>
           <a:prstGeom prst="roundRect">
             <a:avLst>
-              <a:gd name="adj" fmla="val 6522"/>
+              <a:gd name="adj" fmla="val 4225"/>
             </a:avLst>
           </a:prstGeom>
           <a:solidFill>
@@ -10628,14 +10657,14 @@
       </p:sp>
       <p:sp>
         <p:nvSpPr>
-          <p:cNvPr id="17" name="Shape 14"/>
-          <p:cNvSpPr/>
-          <p:nvPr/>
-        </p:nvSpPr>
-        <p:spPr>
-          <a:xfrm>
-            <a:off x="4617720" y="3090672"/>
-            <a:ext cx="73152" cy="841248"/>
+          <p:cNvPr id="18" name="Shape 15"/>
+          <p:cNvSpPr/>
+          <p:nvPr/>
+        </p:nvSpPr>
+        <p:spPr>
+          <a:xfrm>
+            <a:off x="6080760" y="2514600"/>
+            <a:ext cx="73152" cy="1298448"/>
           </a:xfrm>
           <a:prstGeom prst="rect">
             <a:avLst/>
@@ -10653,14 +10682,14 @@
       </p:sp>
       <p:sp>
         <p:nvSpPr>
-          <p:cNvPr id="18" name="Text 15"/>
-          <p:cNvSpPr/>
-          <p:nvPr/>
-        </p:nvSpPr>
-        <p:spPr>
-          <a:xfrm>
-            <a:off x="4818888" y="3255264"/>
-            <a:ext cx="3666744" cy="201168"/>
+          <p:cNvPr id="19" name="Text 16"/>
+          <p:cNvSpPr/>
+          <p:nvPr/>
+        </p:nvSpPr>
+        <p:spPr>
+          <a:xfrm>
+            <a:off x="6281928" y="2679192"/>
+            <a:ext cx="2203704" cy="201168"/>
           </a:xfrm>
           <a:prstGeom prst="rect">
             <a:avLst/>
@@ -10694,14 +10723,14 @@
       </p:sp>
       <p:sp>
         <p:nvSpPr>
-          <p:cNvPr id="19" name="Text 16"/>
-          <p:cNvSpPr/>
-          <p:nvPr/>
-        </p:nvSpPr>
-        <p:spPr>
-          <a:xfrm>
-            <a:off x="4818888" y="3593592"/>
-            <a:ext cx="3666744" cy="219456"/>
+          <p:cNvPr id="20" name="Text 17"/>
+          <p:cNvSpPr/>
+          <p:nvPr/>
+        </p:nvSpPr>
+        <p:spPr>
+          <a:xfrm>
+            <a:off x="6281928" y="3017520"/>
+            <a:ext cx="2203704" cy="676656"/>
           </a:xfrm>
           <a:prstGeom prst="rect">
             <a:avLst/>
@@ -10735,7 +10764,7 @@
       </p:sp>
       <p:sp>
         <p:nvSpPr>
-          <p:cNvPr id="20" name="Text 17"/>
+          <p:cNvPr id="21" name="Text 18"/>
           <p:cNvSpPr/>
           <p:nvPr/>
         </p:nvSpPr>
@@ -10973,9 +11002,38 @@
           </a:p>
         </p:txBody>
       </p:sp>
+      <p:sp>
+        <p:nvSpPr>
+          <p:cNvPr id="7" name="Shape 5"/>
+          <p:cNvSpPr/>
+          <p:nvPr/>
+        </p:nvSpPr>
+        <p:spPr>
+          <a:xfrm>
+            <a:off x="621792" y="1005840"/>
+            <a:ext cx="7909560" cy="969264"/>
+          </a:xfrm>
+          <a:prstGeom prst="roundRect">
+            <a:avLst>
+              <a:gd name="adj" fmla="val 5660"/>
+            </a:avLst>
+          </a:prstGeom>
+          <a:solidFill>
+            <a:srgbClr val="FFFFFF"/>
+          </a:solidFill>
+          <a:ln w="12700">
+            <a:solidFill>
+              <a:srgbClr val="D4D4D4">
+                <a:alpha val="90000"/>
+              </a:srgbClr>
+            </a:solidFill>
+            <a:prstDash val="solid"/>
+          </a:ln>
+        </p:spPr>
+      </p:sp>
       <p:pic>
         <p:nvPicPr>
-          <p:cNvPr id="7" name="Image 0" descr="/Users/fupengcheng/Documents/OpenFugu/assets/02_svf.png">    </p:cNvPr>
+          <p:cNvPr id="8" name="Image 0" descr="/Users/fupengcheng/Documents/OpenFugu/assets/02_svf.png">    </p:cNvPr>
           <p:cNvPicPr>
             <a:picLocks noChangeAspect="1"/>
           </p:cNvPicPr>
@@ -10989,8 +11047,8 @@
         </p:blipFill>
         <p:spPr>
           <a:xfrm>
-            <a:off x="548640" y="960120"/>
-            <a:ext cx="3749040" cy="3429000"/>
+            <a:off x="621792" y="1006438"/>
+            <a:ext cx="7909560" cy="968069"/>
           </a:xfrm>
           <a:prstGeom prst="rect">
             <a:avLst/>
@@ -10999,13 +11057,13 @@
       </p:pic>
       <p:sp>
         <p:nvSpPr>
-          <p:cNvPr id="8" name="Text 5"/>
-          <p:cNvSpPr/>
-          <p:nvPr/>
-        </p:nvSpPr>
-        <p:spPr>
-          <a:xfrm>
-            <a:off x="4800600" y="1234440"/>
+          <p:cNvPr id="9" name="Text 6"/>
+          <p:cNvSpPr/>
+          <p:nvPr/>
+        </p:nvSpPr>
+        <p:spPr>
+          <a:xfrm>
+            <a:off x="868680" y="2423160"/>
             <a:ext cx="3291840" cy="310896"/>
           </a:xfrm>
           <a:prstGeom prst="rect">
@@ -11038,13 +11096,13 @@
       </p:sp>
       <p:sp>
         <p:nvSpPr>
-          <p:cNvPr id="9" name="Text 6"/>
-          <p:cNvSpPr/>
-          <p:nvPr/>
-        </p:nvSpPr>
-        <p:spPr>
-          <a:xfrm>
-            <a:off x="4800600" y="1874520"/>
+          <p:cNvPr id="10" name="Text 7"/>
+          <p:cNvSpPr/>
+          <p:nvPr/>
+        </p:nvSpPr>
+        <p:spPr>
+          <a:xfrm>
+            <a:off x="868680" y="3063240"/>
             <a:ext cx="3474720" cy="310896"/>
           </a:xfrm>
           <a:prstGeom prst="rect">
@@ -11077,14 +11135,14 @@
       </p:sp>
       <p:sp>
         <p:nvSpPr>
-          <p:cNvPr id="10" name="Text 7"/>
-          <p:cNvSpPr/>
-          <p:nvPr/>
-        </p:nvSpPr>
-        <p:spPr>
-          <a:xfrm>
-            <a:off x="4892040" y="2606040"/>
-            <a:ext cx="3429000" cy="1188720"/>
+          <p:cNvPr id="11" name="Text 8"/>
+          <p:cNvSpPr/>
+          <p:nvPr/>
+        </p:nvSpPr>
+        <p:spPr>
+          <a:xfrm>
+            <a:off x="4617720" y="2423160"/>
+            <a:ext cx="3657600" cy="1143000"/>
           </a:xfrm>
           <a:prstGeom prst="rect">
             <a:avLst/>
@@ -12001,9 +12059,38 @@
           </a:p>
         </p:txBody>
       </p:sp>
+      <p:sp>
+        <p:nvSpPr>
+          <p:cNvPr id="26" name="Shape 24"/>
+          <p:cNvSpPr/>
+          <p:nvPr/>
+        </p:nvSpPr>
+        <p:spPr>
+          <a:xfrm>
+            <a:off x="658368" y="2395728"/>
+            <a:ext cx="7818120" cy="658368"/>
+          </a:xfrm>
+          <a:prstGeom prst="roundRect">
+            <a:avLst>
+              <a:gd name="adj" fmla="val 8333"/>
+            </a:avLst>
+          </a:prstGeom>
+          <a:solidFill>
+            <a:srgbClr val="FFFFFF"/>
+          </a:solidFill>
+          <a:ln w="12700">
+            <a:solidFill>
+              <a:srgbClr val="D4D4D4">
+                <a:alpha val="90000"/>
+              </a:srgbClr>
+            </a:solidFill>
+            <a:prstDash val="solid"/>
+          </a:ln>
+        </p:spPr>
+      </p:sp>
       <p:pic>
         <p:nvPicPr>
-          <p:cNvPr id="26" name="Image 0" descr="/Users/fupengcheng/Documents/OpenFugu/assets/04_sepcma.png">    </p:cNvPr>
+          <p:cNvPr id="27" name="Image 0" descr="/Users/fupengcheng/Documents/OpenFugu/assets/04_sepcma.png">    </p:cNvPr>
           <p:cNvPicPr>
             <a:picLocks noChangeAspect="1"/>
           </p:cNvPicPr>
@@ -12017,8 +12104,8 @@
         </p:blipFill>
         <p:spPr>
           <a:xfrm>
-            <a:off x="658368" y="2487168"/>
-            <a:ext cx="3840480" cy="1783080"/>
+            <a:off x="658368" y="2531655"/>
+            <a:ext cx="7818120" cy="386514"/>
           </a:xfrm>
           <a:prstGeom prst="rect">
             <a:avLst/>
@@ -12027,18 +12114,18 @@
       </p:pic>
       <p:sp>
         <p:nvSpPr>
-          <p:cNvPr id="27" name="Shape 24"/>
-          <p:cNvSpPr/>
-          <p:nvPr/>
-        </p:nvSpPr>
-        <p:spPr>
-          <a:xfrm>
-            <a:off x="4800600" y="2487168"/>
-            <a:ext cx="3566160" cy="1783080"/>
+          <p:cNvPr id="28" name="Shape 25"/>
+          <p:cNvSpPr/>
+          <p:nvPr/>
+        </p:nvSpPr>
+        <p:spPr>
+          <a:xfrm>
+            <a:off x="960120" y="3310128"/>
+            <a:ext cx="7223760" cy="1005840"/>
           </a:xfrm>
           <a:prstGeom prst="roundRect">
             <a:avLst>
-              <a:gd name="adj" fmla="val 3077"/>
+              <a:gd name="adj" fmla="val 5455"/>
             </a:avLst>
           </a:prstGeom>
           <a:solidFill>
@@ -12056,14 +12143,14 @@
       </p:sp>
       <p:sp>
         <p:nvSpPr>
-          <p:cNvPr id="28" name="Shape 25"/>
-          <p:cNvSpPr/>
-          <p:nvPr/>
-        </p:nvSpPr>
-        <p:spPr>
-          <a:xfrm>
-            <a:off x="4800600" y="2487168"/>
-            <a:ext cx="73152" cy="1783080"/>
+          <p:cNvPr id="29" name="Shape 26"/>
+          <p:cNvSpPr/>
+          <p:nvPr/>
+        </p:nvSpPr>
+        <p:spPr>
+          <a:xfrm>
+            <a:off x="960120" y="3310128"/>
+            <a:ext cx="73152" cy="1005840"/>
           </a:xfrm>
           <a:prstGeom prst="rect">
             <a:avLst/>
@@ -12081,14 +12168,14 @@
       </p:sp>
       <p:sp>
         <p:nvSpPr>
-          <p:cNvPr id="29" name="Text 26"/>
-          <p:cNvSpPr/>
-          <p:nvPr/>
-        </p:nvSpPr>
-        <p:spPr>
-          <a:xfrm>
-            <a:off x="5001768" y="2651760"/>
-            <a:ext cx="3255264" cy="201168"/>
+          <p:cNvPr id="30" name="Text 27"/>
+          <p:cNvSpPr/>
+          <p:nvPr/>
+        </p:nvSpPr>
+        <p:spPr>
+          <a:xfrm>
+            <a:off x="1161288" y="3474720"/>
+            <a:ext cx="6912864" cy="201168"/>
           </a:xfrm>
           <a:prstGeom prst="rect">
             <a:avLst/>
@@ -12122,14 +12209,14 @@
       </p:sp>
       <p:sp>
         <p:nvSpPr>
-          <p:cNvPr id="30" name="Text 27"/>
-          <p:cNvSpPr/>
-          <p:nvPr/>
-        </p:nvSpPr>
-        <p:spPr>
-          <a:xfrm>
-            <a:off x="5001768" y="2990088"/>
-            <a:ext cx="3255264" cy="1161288"/>
+          <p:cNvPr id="31" name="Text 28"/>
+          <p:cNvSpPr/>
+          <p:nvPr/>
+        </p:nvSpPr>
+        <p:spPr>
+          <a:xfrm>
+            <a:off x="1161288" y="3813048"/>
+            <a:ext cx="6912864" cy="384048"/>
           </a:xfrm>
           <a:prstGeom prst="rect">
             <a:avLst/>

</xml_diff>